<commit_message>
powerpoint del proyecto final
</commit_message>
<xml_diff>
--- a/docs/PowerPoint Hito 5.pptx
+++ b/docs/PowerPoint Hito 5.pptx
@@ -519,10 +519,6 @@
           <a:bodyPr/>
           <a:lstStyle/>
           <a:p>
-            <a:r>
-              <a:rPr lang="en-US" dirty="0"/>
-              <a:t>Equipo. Buenas noches. Somos el Grupo 2 y presentamos la entrega final de Power Strike, un sistema de gestión de gimnasio. Durante el trabajo de campo migramos el sistema a una arquitectura moderna y, sobre todo, construimos un proceso de calidad. La presentación está dividida por temas y cada integrante expone su parte.</a:t>
-            </a:r>
             <a:endParaRPr lang="en-US" dirty="0"/>
           </a:p>
         </p:txBody>
@@ -607,10 +603,6 @@
           <a:bodyPr/>
           <a:lstStyle/>
           <a:p>
-            <a:r>
-              <a:rPr lang="en-US" dirty="0"/>
-              <a:t>Martín. Una de las técnicas que más nos sirvió fue modelar la asistencia como una máquina de estados. Un usuario pasa de no tener registro, a tener una asistencia registrada; y si intenta registrar otra el mismo día, el sistema lo rechaza con un 409. Dibujar los estados y las transiciones nos permitió derivar casos de prueba concretos y, de paso, nos hizo descubrir que originalmente se permitían asistencias duplicadas: ese fue uno de los defectos que corregimos.</a:t>
-            </a:r>
             <a:endParaRPr lang="en-US" dirty="0"/>
           </a:p>
         </p:txBody>
@@ -695,10 +687,6 @@
           <a:bodyPr/>
           <a:lstStyle/>
           <a:p>
-            <a:r>
-              <a:rPr lang="en-US" dirty="0"/>
-              <a:t>Martín. Todo este testing no sirve si alguien se olvida de correrlo. Por eso montamos integración continua con GitHub Actions: en cada push se compila el proyecto, se corren los 77 tests y se genera el reporte de cobertura, además de los análisis estáticos con PMD, Checkstyle y ESLint. Si algo se rompe, el pipeline lo marca antes de integrar. Así la calidad deja de depender de que cada uno se acuerde, y la rama principal se mantiene siempre estable.</a:t>
-            </a:r>
             <a:endParaRPr lang="en-US" dirty="0"/>
           </a:p>
         </p:txBody>
@@ -783,10 +771,6 @@
           <a:bodyPr/>
           <a:lstStyle/>
           <a:p>
-            <a:r>
-              <a:rPr lang="en-US" dirty="0"/>
-              <a:t>Mateo. Vamos a los números del cierre. El sistema tiene unas 1.585 líneas de producción y 839 de tests, una razón de 0,53: más de media línea de test por cada línea de código. En complejidad, PMD no reporta ninguna violación: el método más complejo tiene complejidad ciclomática 3, muy por debajo del umbral de 10. Y el índice de mantenibilidad estimado ronda 85, que en la escala SEI es alta mantenibilidad. O sea: código chico, simple y mantenible.</a:t>
-            </a:r>
             <a:endParaRPr lang="en-US" dirty="0"/>
           </a:p>
         </p:txBody>
@@ -871,10 +855,6 @@
           <a:bodyPr/>
           <a:lstStyle/>
           <a:p>
-            <a:r>
-              <a:rPr lang="en-US" dirty="0"/>
-              <a:t>Mateo. En cobertura distinguimos dos números. En los módulos principales —controllers, servicios y modelos— tenemos 100%, bastante por encima del 60% que pide el plan. El global da 53%, y eso es honesto: lo que queda sin cubrir es la capa de seguridad y el arranque de Spring, que no son parte del testing funcional. Y la suite completa, 77 tests, está toda en verde. Si miramos la evolución, pasamos de 21 tests en el Hito 3 a 77 ahora. Con esto cierro mi parte y le paso a Ernesto.</a:t>
-            </a:r>
             <a:endParaRPr lang="en-US" dirty="0"/>
           </a:p>
         </p:txBody>
@@ -959,10 +939,6 @@
           <a:bodyPr/>
           <a:lstStyle/>
           <a:p>
-            <a:r>
-              <a:rPr lang="en-US" dirty="0"/>
-              <a:t>Ernesto. Buenas. Yo me encargué del testing exploratorio y la gestión de defectos. Detectamos 12 en total: 6 por análisis y TDD, y 6 más probando la aplicación a mano. Lo importante es el criterio: cada defecto se carga como Issue con su severidad, que la define QA, y su prioridad, que la define el dueño del producto. De los 12, ya cerramos 9, incluido el crítico. Quedan 3 abiertos, documentados para próximos avances. Que haya una densidad alta no es mala señal: significa que los buscamos activamente.</a:t>
-            </a:r>
             <a:endParaRPr lang="en-US" dirty="0"/>
           </a:p>
         </p:txBody>
@@ -1047,10 +1023,6 @@
           <a:bodyPr/>
           <a:lstStyle/>
           <a:p>
-            <a:r>
-              <a:rPr lang="en-US" dirty="0"/>
-              <a:t>Ernesto. Esta filmina es el corazón del Hito 5: los defectos que cerramos, todos con TDD. El más importante, el crítico DEF-EXP-04: ahora la gestión de usuarios exige rol ADMIN y un CLIENT recibe 403. Después: las asistencias duplicadas ahora devuelven 409; un usuario inexistente devuelve 404 en lugar del 500 que daba antes; y el día de la actividad se valida y devuelve 400 si es inválido. En los cuatro casos primero escribimos el test que fallaba y después el arreglo.</a:t>
-            </a:r>
             <a:endParaRPr lang="en-US" dirty="0"/>
           </a:p>
         </p:txBody>
@@ -1135,10 +1107,6 @@
           <a:bodyPr/>
           <a:lstStyle/>
           <a:p>
-            <a:r>
-              <a:rPr lang="en-US" dirty="0"/>
-              <a:t>Fabricio. Como parte de la documentación de calidad hicimos un análisis FMEA sobre la funcionalidad más sensible, el registro de usuarios. Identificamos los modos de falla posibles, los priorizamos con el Número de Prioridad de Riesgo —que combina gravedad, ocurrencia y detección— y los riesgos más altos los convertimos en acciones concretas: validaciones en el backend y tests que las cubren. Es la forma de no dejar la calidad librada a la intuición.</a:t>
-            </a:r>
             <a:endParaRPr lang="en-US" dirty="0"/>
           </a:p>
         </p:txBody>
@@ -1223,10 +1191,6 @@
           <a:bodyPr/>
           <a:lstStyle/>
           <a:p>
-            <a:r>
-              <a:rPr lang="en-US" dirty="0"/>
-              <a:t>Ernesto. Por último, evaluamos la usabilidad con las 10 heurísticas de Nielsen sobre las cinco pantallas. Encontramos 2 problemas mayores, 5 menores y 3 cosméticos. Los más relevantes: falta una confirmación antes de eliminar, el mensaje al borrar un usuario con asistencias no es claro, y conviene un buscador de usuario al registrar asistencia. Lo dejamos priorizado. Importante: el problema de control de roles, que también era de usabilidad y seguridad, ya quedó resuelto en este hito.</a:t>
-            </a:r>
             <a:endParaRPr lang="en-US" dirty="0"/>
           </a:p>
         </p:txBody>
@@ -1311,10 +1275,6 @@
           <a:bodyPr/>
           <a:lstStyle/>
           <a:p>
-            <a:r>
-              <a:rPr lang="en-US" dirty="0"/>
-              <a:t>Equipo (lo hace quien tenga el entorno levantado). Pasamos a la demo. Mostramos el login, la gestión de usuarios, las actividades y el registro de asistencias. Y al final, para evidenciar la corrección del defecto crítico, intentamos acceder a la gestión de usuarios con un rol CLIENT y se ve que el sistema responde 403. Los wireframes y mockups de estas pantallas están en nuestro proyecto de Figma.</a:t>
-            </a:r>
             <a:endParaRPr lang="en-US" dirty="0"/>
           </a:p>
         </p:txBody>
@@ -1399,10 +1359,6 @@
           <a:bodyPr/>
           <a:lstStyle/>
           <a:p>
-            <a:r>
-              <a:rPr lang="en-US" dirty="0"/>
-              <a:t>Equipo. Para cerrar, la reflexión. Lo que más valoramos haber aprendido es a tratar el testing como parte del desarrollo y no como un agregado final, a justificar los casos con técnicas formales, a leer las métricas con criterio y a apoyarnos en la integración continua. Y si lo volviéramos a hacer: testearíamos desde el día uno, implementaríamos el control de roles mucho antes, reforzaríamos la validación en el frontend y cerraríamos los defectos abiertos antes de la entrega.</a:t>
-            </a:r>
             <a:endParaRPr lang="en-US" dirty="0"/>
           </a:p>
         </p:txBody>
@@ -1487,10 +1443,6 @@
           <a:bodyPr/>
           <a:lstStyle/>
           <a:p>
-            <a:r>
-              <a:rPr lang="en-US" dirty="0"/>
-              <a:t>Mateo. Antes de entrar en tema, así repartimos la defensa: yo cubro el producto, el testing automatizado y las métricas; Martín explica la arquitectura, la máquina de estados y la integración continua; Fabricio se encarga del Plan SQA, la trazabilidad y el FMEA; y Ernesto cierra con la gestión de defectos y el análisis de usabilidad. La demo y las conclusiones las hacemos entre todos.</a:t>
-            </a:r>
             <a:endParaRPr lang="en-US" dirty="0"/>
           </a:p>
         </p:txBody>
@@ -1575,10 +1527,6 @@
           <a:bodyPr/>
           <a:lstStyle/>
           <a:p>
-            <a:r>
-              <a:rPr lang="en-US" dirty="0"/>
-              <a:t>Equipo. En conclusión, entregamos un producto funcional pero, más importante, un método de calidad que podemos replicar en cualquier proyecto: 77 tests en verde, 100% de cobertura en los módulos principales, integración continua activa, trazabilidad completa y el defecto crítico cerrado. Muchas gracias, quedamos para sus preguntas.</a:t>
-            </a:r>
             <a:endParaRPr lang="en-US" dirty="0"/>
           </a:p>
         </p:txBody>
@@ -1663,10 +1611,6 @@
           <a:bodyPr/>
           <a:lstStyle/>
           <a:p>
-            <a:r>
-              <a:rPr lang="en-US" dirty="0"/>
-              <a:t>Mateo. Power Strike resuelve la operación diaria de un gimnasio: gestiona usuarios con sus validaciones, las actividades que se dictan, y el registro de asistencias. Todo detrás de un login con JWT y control de acceso por rol. Son cinco pantallas, pero el foco del trabajo no fue la cantidad de features sino la calidad con que están construidas y verificadas.</a:t>
-            </a:r>
             <a:endParaRPr lang="en-US" dirty="0"/>
           </a:p>
         </p:txBody>
@@ -1751,10 +1695,6 @@
           <a:bodyPr/>
           <a:lstStyle/>
           <a:p>
-            <a:r>
-              <a:rPr lang="en-US" dirty="0"/>
-              <a:t>Martín. La aplicación sigue una arquitectura en capas clásica. El frontend es una SPA en Vue 3 que consume una API REST en Spring Boot. Los controllers reciben las peticiones, delegan en los servicios que tienen la lógica de negocio, y estos usan repositorios de Spring Data sobre PostgreSQL. Lo importante de esta separación es que cada capa se puede testear por separado: los servicios con dobles de prueba y los controllers vía HTTP. Eso es lo que hizo posible toda la estrategia de testing que va a contar Mateo.</a:t>
-            </a:r>
             <a:endParaRPr lang="en-US" dirty="0"/>
           </a:p>
         </p:txBody>
@@ -1839,10 +1779,6 @@
           <a:bodyPr/>
           <a:lstStyle/>
           <a:p>
-            <a:r>
-              <a:rPr lang="en-US" dirty="0"/>
-              <a:t>Fabricio. Todo esto no fue improvisado: lo guía un Plan SQA que venimos actualizando desde el Hito 3. El plan define qué controlamos —trazabilidad, cobertura, complejidad y defectos—, cómo lo medimos —de forma automática en cada push y revisado por hito— y qué umbrales tienen que cumplirse para aprobar un cambio: al menos 60% de cobertura en código nuevo, complejidad ciclomática menor o igual a 10, la suite entera en verde, y cero defectos críticos abiertos al mergear. En las próximas filminas muestro cómo se cumplieron.</a:t>
-            </a:r>
             <a:endParaRPr lang="en-US" dirty="0"/>
           </a:p>
         </p:txBody>
@@ -1927,10 +1863,6 @@
           <a:bodyPr/>
           <a:lstStyle/>
           <a:p>
-            <a:r>
-              <a:rPr lang="en-US" dirty="0"/>
-              <a:t>Fabricio. Esta es la matriz de trazabilidad de los requerimientos funcionales. Cada uno de los cinco está implementado y, sobre todo, verificado con tests automatizados que referencian su caso de diseño: los CP para usuarios, los AC para actividades y los AT para asistencias. La traza es completa: de cada requerimiento puedo llegar al código y al test que lo prueba, y al revés.</a:t>
-            </a:r>
             <a:endParaRPr lang="en-US" dirty="0"/>
           </a:p>
         </p:txBody>
@@ -2015,10 +1947,6 @@
           <a:bodyPr/>
           <a:lstStyle/>
           <a:p>
-            <a:r>
-              <a:rPr lang="en-US" dirty="0"/>
-              <a:t>Fabricio. Además de lo funcional, trazamos los requerimientos no funcionales: la autenticación con JWT, la autorización por rol y el manejo coherente de errores HTTP. Marco especialmente el del medio: el control de roles. En el Hito 4 era nuestro defecto crítico abierto, un CLIENT podía acceder a todo. En el Hito 5 lo cerramos con anotaciones de seguridad y un test que prueba que un CLIENT recibe 403 y un ADMIN 200. Ernesto va a dar el detalle cuando hable de defectos.</a:t>
-            </a:r>
             <a:endParaRPr lang="en-US" dirty="0"/>
           </a:p>
         </p:txBody>
@@ -2103,10 +2031,6 @@
           <a:bodyPr/>
           <a:lstStyle/>
           <a:p>
-            <a:r>
-              <a:rPr lang="en-US" dirty="0"/>
-              <a:t>Mateo. Nuestra estrategia de testing tiene dos niveles. Caja negra: 55 tests sobre los controllers usando MockMvc, que prueban las validaciones y el manejo de errores por HTTP, sin levantar la base, verificando la especificación. Y caja blanca: 22 tests sobre los servicios con Mockito, que cubren las ramas internas y los casos límite. En total 77 tests. Y no los escribimos a ojo: cada caso responde a una técnica formal de diseño —partición de equivalencia, valores límite, tabla de decisión y máquina de estados.</a:t>
-            </a:r>
             <a:endParaRPr lang="en-US" dirty="0"/>
           </a:p>
         </p:txBody>
@@ -2191,10 +2115,6 @@
           <a:bodyPr/>
           <a:lstStyle/>
           <a:p>
-            <a:r>
-              <a:rPr lang="en-US" dirty="0"/>
-              <a:t>Mateo. Sobre las funcionalidades nuevas aplicamos TDD. El ciclo es: primero escribimos el test, que falla porque la lógica no existe —fase roja—; después implementamos lo mínimo para que pase —fase verde—; y por último refactorizamos con los tests como red de seguridad. Lo interesante es que esto queda registrado en el historial de Git: se ve el commit del test que falla y después el commit del fix. Eso es evidencia objetiva de que aplicamos la metodología.</a:t>
-            </a:r>
             <a:endParaRPr lang="en-US" dirty="0"/>
           </a:p>
         </p:txBody>

</xml_diff>

<commit_message>
docs: cierre DEF-EXP-03 y coherencia de defectos (9 corregidos/3 abiertos, 78 tests) en todos los documentos y presentacion
</commit_message>
<xml_diff>
--- a/docs/PowerPoint Hito 5.pptx
+++ b/docs/PowerPoint Hito 5.pptx
@@ -2505,6 +2505,10 @@
           </a:solidFill>
           <a:ln/>
         </p:spPr>
+        <p:txBody>
+          <a:bodyPr/>
+          <a:p/>
+        </p:txBody>
       </p:sp>
       <p:sp>
         <p:nvSpPr>
@@ -2525,6 +2529,10 @@
           </a:solidFill>
           <a:ln/>
         </p:spPr>
+        <p:txBody>
+          <a:bodyPr/>
+          <a:p/>
+        </p:txBody>
       </p:sp>
       <p:sp>
         <p:nvSpPr>
@@ -2772,6 +2780,10 @@
           </a:solidFill>
           <a:ln/>
         </p:spPr>
+        <p:txBody>
+          <a:bodyPr/>
+          <a:p/>
+        </p:txBody>
       </p:sp>
       <p:sp>
         <p:nvSpPr>
@@ -2916,6 +2928,10 @@
             <a:prstDash val="solid"/>
           </a:ln>
         </p:spPr>
+        <p:txBody>
+          <a:bodyPr/>
+          <a:p/>
+        </p:txBody>
       </p:sp>
       <p:sp>
         <p:nvSpPr>
@@ -3021,6 +3037,10 @@
             <a:prstDash val="solid"/>
           </a:ln>
         </p:spPr>
+        <p:txBody>
+          <a:bodyPr/>
+          <a:p/>
+        </p:txBody>
       </p:sp>
       <p:sp>
         <p:nvSpPr>
@@ -3126,6 +3146,10 @@
             <a:prstDash val="solid"/>
           </a:ln>
         </p:spPr>
+        <p:txBody>
+          <a:bodyPr/>
+          <a:p/>
+        </p:txBody>
       </p:sp>
       <p:sp>
         <p:nvSpPr>
@@ -3295,6 +3319,10 @@
           </a:solidFill>
           <a:ln/>
         </p:spPr>
+        <p:txBody>
+          <a:bodyPr/>
+          <a:p/>
+        </p:txBody>
       </p:sp>
       <p:sp>
         <p:nvSpPr>
@@ -3434,6 +3462,10 @@
           </a:solidFill>
           <a:ln/>
         </p:spPr>
+        <p:txBody>
+          <a:bodyPr/>
+          <a:p/>
+        </p:txBody>
       </p:sp>
       <p:sp>
         <p:nvSpPr>
@@ -3454,6 +3486,10 @@
           </a:solidFill>
           <a:ln/>
         </p:spPr>
+        <p:txBody>
+          <a:bodyPr/>
+          <a:p/>
+        </p:txBody>
       </p:sp>
       <p:sp>
         <p:nvSpPr>
@@ -3527,7 +3563,7 @@
                 <a:ea typeface="Arial" pitchFamily="34" charset="-122"/>
                 <a:cs typeface="Arial" pitchFamily="34" charset="-120"/>
               </a:rPr>
-              <a:t>GitHub Actions compila, corre los 77 tests y genera el reporte de cobertura JaCoCo.</a:t>
+              <a:t>GitHub Actions compila, corre los 78 tests y genera el reporte de cobertura JaCoCo.</a:t>
             </a:r>
             <a:endParaRPr lang="en-US" sz="1100" dirty="0"/>
           </a:p>
@@ -3554,6 +3590,10 @@
           </a:solidFill>
           <a:ln/>
         </p:spPr>
+        <p:txBody>
+          <a:bodyPr/>
+          <a:p/>
+        </p:txBody>
       </p:sp>
       <p:sp>
         <p:nvSpPr>
@@ -3574,6 +3614,10 @@
           </a:solidFill>
           <a:ln/>
         </p:spPr>
+        <p:txBody>
+          <a:bodyPr/>
+          <a:p/>
+        </p:txBody>
       </p:sp>
       <p:sp>
         <p:nvSpPr>
@@ -3674,6 +3718,10 @@
           </a:solidFill>
           <a:ln/>
         </p:spPr>
+        <p:txBody>
+          <a:bodyPr/>
+          <a:p/>
+        </p:txBody>
       </p:sp>
       <p:sp>
         <p:nvSpPr>
@@ -3694,6 +3742,10 @@
           </a:solidFill>
           <a:ln/>
         </p:spPr>
+        <p:txBody>
+          <a:bodyPr/>
+          <a:p/>
+        </p:txBody>
       </p:sp>
       <p:sp>
         <p:nvSpPr>
@@ -3902,6 +3954,10 @@
           </a:solidFill>
           <a:ln/>
         </p:spPr>
+        <p:txBody>
+          <a:bodyPr/>
+          <a:p/>
+        </p:txBody>
       </p:sp>
       <p:sp>
         <p:nvSpPr>
@@ -4041,6 +4097,10 @@
           </a:solidFill>
           <a:ln/>
         </p:spPr>
+        <p:txBody>
+          <a:bodyPr/>
+          <a:p/>
+        </p:txBody>
       </p:sp>
       <p:sp>
         <p:nvSpPr>
@@ -4061,6 +4121,10 @@
           </a:solidFill>
           <a:ln/>
         </p:spPr>
+        <p:txBody>
+          <a:bodyPr/>
+          <a:p/>
+        </p:txBody>
       </p:sp>
       <p:sp>
         <p:nvSpPr>
@@ -4200,6 +4264,10 @@
           </a:solidFill>
           <a:ln/>
         </p:spPr>
+        <p:txBody>
+          <a:bodyPr/>
+          <a:p/>
+        </p:txBody>
       </p:sp>
       <p:sp>
         <p:nvSpPr>
@@ -4220,6 +4288,10 @@
           </a:solidFill>
           <a:ln/>
         </p:spPr>
+        <p:txBody>
+          <a:bodyPr/>
+          <a:p/>
+        </p:txBody>
       </p:sp>
       <p:sp>
         <p:nvSpPr>
@@ -4359,6 +4431,10 @@
           </a:solidFill>
           <a:ln/>
         </p:spPr>
+        <p:txBody>
+          <a:bodyPr/>
+          <a:p/>
+        </p:txBody>
       </p:sp>
       <p:sp>
         <p:nvSpPr>
@@ -4379,6 +4455,10 @@
           </a:solidFill>
           <a:ln/>
         </p:spPr>
+        <p:txBody>
+          <a:bodyPr/>
+          <a:p/>
+        </p:txBody>
       </p:sp>
       <p:sp>
         <p:nvSpPr>
@@ -4587,6 +4667,10 @@
           </a:solidFill>
           <a:ln/>
         </p:spPr>
+        <p:txBody>
+          <a:bodyPr/>
+          <a:p/>
+        </p:txBody>
       </p:sp>
       <p:sp>
         <p:nvSpPr>
@@ -4726,6 +4810,10 @@
           </a:solidFill>
           <a:ln/>
         </p:spPr>
+        <p:txBody>
+          <a:bodyPr/>
+          <a:p/>
+        </p:txBody>
       </p:sp>
       <p:sp>
         <p:nvSpPr>
@@ -4746,6 +4834,10 @@
           </a:solidFill>
           <a:ln/>
         </p:spPr>
+        <p:txBody>
+          <a:bodyPr/>
+          <a:p/>
+        </p:txBody>
       </p:sp>
       <p:sp>
         <p:nvSpPr>
@@ -4885,6 +4977,10 @@
           </a:solidFill>
           <a:ln/>
         </p:spPr>
+        <p:txBody>
+          <a:bodyPr/>
+          <a:p/>
+        </p:txBody>
       </p:sp>
       <p:sp>
         <p:nvSpPr>
@@ -4905,6 +5001,10 @@
           </a:solidFill>
           <a:ln/>
         </p:spPr>
+        <p:txBody>
+          <a:bodyPr/>
+          <a:p/>
+        </p:txBody>
       </p:sp>
       <p:sp>
         <p:nvSpPr>
@@ -5044,6 +5144,10 @@
           </a:solidFill>
           <a:ln/>
         </p:spPr>
+        <p:txBody>
+          <a:bodyPr/>
+          <a:p/>
+        </p:txBody>
       </p:sp>
       <p:sp>
         <p:nvSpPr>
@@ -5064,6 +5168,10 @@
           </a:solidFill>
           <a:ln/>
         </p:spPr>
+        <p:txBody>
+          <a:bodyPr/>
+          <a:p/>
+        </p:txBody>
       </p:sp>
       <p:sp>
         <p:nvSpPr>
@@ -5098,7 +5206,7 @@
                 <a:ea typeface="Arial Black" pitchFamily="34" charset="-122"/>
                 <a:cs typeface="Arial Black" pitchFamily="34" charset="-120"/>
               </a:rPr>
-              <a:t>77</a:t>
+              <a:t>78</a:t>
             </a:r>
             <a:endParaRPr lang="en-US" sz="3000" dirty="0"/>
           </a:p>
@@ -5215,7 +5323,7 @@
                 <a:ea typeface="Arial" pitchFamily="34" charset="-122"/>
                 <a:cs typeface="Arial" pitchFamily="34" charset="-120"/>
               </a:rPr>
-              <a:t>Evolución: 21 tests (H3) → 72 (H4) → 77 (H5). Cobertura de módulos principales: parcial → 100%.</a:t>
+              <a:t>Evolución: 21 tests (H3) → 72 (H4) → 78 (H5). Cobertura de módulos principales: parcial → 100%.</a:t>
             </a:r>
             <a:endParaRPr lang="en-US" sz="1300" dirty="0"/>
           </a:p>
@@ -5311,6 +5419,10 @@
           </a:solidFill>
           <a:ln/>
         </p:spPr>
+        <p:txBody>
+          <a:bodyPr/>
+          <a:p/>
+        </p:txBody>
       </p:sp>
       <p:sp>
         <p:nvSpPr>
@@ -5450,6 +5562,10 @@
           </a:solidFill>
           <a:ln/>
         </p:spPr>
+        <p:txBody>
+          <a:bodyPr/>
+          <a:p/>
+        </p:txBody>
       </p:sp>
       <p:sp>
         <p:nvSpPr>
@@ -5470,6 +5586,10 @@
           </a:solidFill>
           <a:ln/>
         </p:spPr>
+        <p:txBody>
+          <a:bodyPr/>
+          <a:p/>
+        </p:txBody>
       </p:sp>
       <p:sp>
         <p:nvSpPr>
@@ -5609,6 +5729,10 @@
           </a:solidFill>
           <a:ln/>
         </p:spPr>
+        <p:txBody>
+          <a:bodyPr/>
+          <a:p/>
+        </p:txBody>
       </p:sp>
       <p:sp>
         <p:nvSpPr>
@@ -5629,6 +5753,10 @@
           </a:solidFill>
           <a:ln/>
         </p:spPr>
+        <p:txBody>
+          <a:bodyPr/>
+          <a:p/>
+        </p:txBody>
       </p:sp>
       <p:sp>
         <p:nvSpPr>
@@ -5768,6 +5896,10 @@
           </a:solidFill>
           <a:ln/>
         </p:spPr>
+        <p:txBody>
+          <a:bodyPr/>
+          <a:p/>
+        </p:txBody>
       </p:sp>
       <p:sp>
         <p:nvSpPr>
@@ -5788,6 +5920,10 @@
           </a:solidFill>
           <a:ln/>
         </p:spPr>
+        <p:txBody>
+          <a:bodyPr/>
+          <a:p/>
+        </p:txBody>
       </p:sp>
       <p:sp>
         <p:nvSpPr>
@@ -5927,6 +6063,10 @@
           </a:solidFill>
           <a:ln/>
         </p:spPr>
+        <p:txBody>
+          <a:bodyPr/>
+          <a:p/>
+        </p:txBody>
       </p:sp>
       <p:sp>
         <p:nvSpPr>
@@ -5947,6 +6087,10 @@
           </a:solidFill>
           <a:ln/>
         </p:spPr>
+        <p:txBody>
+          <a:bodyPr/>
+          <a:p/>
+        </p:txBody>
       </p:sp>
       <p:sp>
         <p:nvSpPr>
@@ -6194,6 +6338,10 @@
           </a:solidFill>
           <a:ln/>
         </p:spPr>
+        <p:txBody>
+          <a:bodyPr/>
+          <a:p/>
+        </p:txBody>
       </p:sp>
       <p:sp>
         <p:nvSpPr>
@@ -6333,6 +6481,10 @@
           </a:solidFill>
           <a:ln/>
         </p:spPr>
+        <p:txBody>
+          <a:bodyPr/>
+          <a:p/>
+        </p:txBody>
       </p:sp>
       <p:sp>
         <p:nvSpPr>
@@ -6472,6 +6624,10 @@
           </a:solidFill>
           <a:ln/>
         </p:spPr>
+        <p:txBody>
+          <a:bodyPr/>
+          <a:p/>
+        </p:txBody>
       </p:sp>
       <p:sp>
         <p:nvSpPr>
@@ -6611,6 +6767,10 @@
           </a:solidFill>
           <a:ln/>
         </p:spPr>
+        <p:txBody>
+          <a:bodyPr/>
+          <a:p/>
+        </p:txBody>
       </p:sp>
       <p:sp>
         <p:nvSpPr>
@@ -6645,7 +6805,7 @@
                 <a:ea typeface="Arial Black" pitchFamily="34" charset="-122"/>
                 <a:cs typeface="Arial Black" pitchFamily="34" charset="-120"/>
               </a:rPr>
-              <a:t>DEF-EXP-01</a:t>
+              <a:t>DEF-EXP-03</a:t>
             </a:r>
             <a:endParaRPr lang="en-US" sz="1400" dirty="0"/>
           </a:p>
@@ -6684,7 +6844,7 @@
                 <a:ea typeface="Arial" pitchFamily="34" charset="-122"/>
                 <a:cs typeface="Arial" pitchFamily="34" charset="-120"/>
               </a:rPr>
-              <a:t>userId inexistente devolvía 500</a:t>
+              <a:t>No se podía editar usuario sin cambiar pass</a:t>
             </a:r>
             <a:endParaRPr lang="en-US" sz="1300" dirty="0"/>
           </a:p>
@@ -6723,7 +6883,7 @@
                 <a:ea typeface="Arial Black" pitchFamily="34" charset="-122"/>
                 <a:cs typeface="Arial Black" pitchFamily="34" charset="-120"/>
               </a:rPr>
-              <a:t>→ 404 NotFound</a:t>
+              <a:t>→ 200 (grupo OnCreate)</a:t>
             </a:r>
             <a:endParaRPr lang="en-US" sz="1300" dirty="0"/>
           </a:p>
@@ -6750,6 +6910,10 @@
           </a:solidFill>
           <a:ln/>
         </p:spPr>
+        <p:txBody>
+          <a:bodyPr/>
+          <a:p/>
+        </p:txBody>
       </p:sp>
       <p:sp>
         <p:nvSpPr>
@@ -6784,7 +6948,7 @@
                 <a:ea typeface="Arial Black" pitchFamily="34" charset="-122"/>
                 <a:cs typeface="Arial Black" pitchFamily="34" charset="-120"/>
               </a:rPr>
-              <a:t>DEF-EXP-06</a:t>
+              <a:t>DEF-EXP-01</a:t>
             </a:r>
             <a:endParaRPr lang="en-US" sz="1400" dirty="0"/>
           </a:p>
@@ -6823,7 +6987,7 @@
                 <a:ea typeface="Arial" pitchFamily="34" charset="-122"/>
                 <a:cs typeface="Arial" pitchFamily="34" charset="-120"/>
               </a:rPr>
-              <a:t>Día de actividad sin validar</a:t>
+              <a:t>userId inexistente devolvía 500</a:t>
             </a:r>
             <a:endParaRPr lang="en-US" sz="1300" dirty="0"/>
           </a:p>
@@ -6862,6 +7026,149 @@
                 <a:ea typeface="Arial Black" pitchFamily="34" charset="-122"/>
                 <a:cs typeface="Arial Black" pitchFamily="34" charset="-120"/>
               </a:rPr>
+              <a:t>→ 404 NotFound</a:t>
+            </a:r>
+            <a:endParaRPr lang="en-US" sz="1300" dirty="0"/>
+          </a:p>
+        </p:txBody>
+      </p:sp>
+      <p:sp>
+        <p:nvSpPr>
+          <p:cNvPr id="22" name="Shape 20"/>
+          <p:cNvSpPr/>
+          <p:nvPr/>
+        </p:nvSpPr>
+        <p:spPr>
+          <a:xfrm>
+            <a:off x="502920" y="5303520"/>
+            <a:ext cx="11201400" cy="749808"/>
+          </a:xfrm>
+          <a:prstGeom prst="roundRect">
+            <a:avLst>
+              <a:gd name="adj" fmla="val 7317"/>
+            </a:avLst>
+          </a:prstGeom>
+          <a:solidFill>
+            <a:srgbClr val="1E2230"/>
+          </a:solidFill>
+          <a:ln/>
+        </p:spPr>
+        <p:txBody>
+          <a:bodyPr/>
+          <a:p/>
+        </p:txBody>
+      </p:sp>
+      <p:sp>
+        <p:nvSpPr>
+          <p:cNvPr id="23" name="Text 21"/>
+          <p:cNvSpPr/>
+          <p:nvPr/>
+        </p:nvSpPr>
+        <p:spPr>
+          <a:xfrm>
+            <a:off x="685800" y="5303520"/>
+            <a:ext cx="1828800" cy="749808"/>
+          </a:xfrm>
+          <a:prstGeom prst="rect">
+            <a:avLst/>
+          </a:prstGeom>
+          <a:noFill/>
+          <a:ln/>
+        </p:spPr>
+        <p:txBody>
+          <a:bodyPr wrap="square" rtlCol="0" anchor="ctr"/>
+          <a:lstStyle/>
+          <a:p>
+            <a:pPr indent="0" marL="0">
+              <a:buNone/>
+            </a:pPr>
+            <a:r>
+              <a:rPr lang="en-US" sz="1400" b="1" dirty="0">
+                <a:solidFill>
+                  <a:srgbClr val="FFB100"/>
+                </a:solidFill>
+                <a:latin typeface="Arial Black" pitchFamily="34" charset="0"/>
+                <a:ea typeface="Arial Black" pitchFamily="34" charset="-122"/>
+                <a:cs typeface="Arial Black" pitchFamily="34" charset="-120"/>
+              </a:rPr>
+              <a:t>DEF-EXP-06</a:t>
+            </a:r>
+            <a:endParaRPr lang="en-US" sz="1400" dirty="0"/>
+          </a:p>
+        </p:txBody>
+      </p:sp>
+      <p:sp>
+        <p:nvSpPr>
+          <p:cNvPr id="24" name="Text 22"/>
+          <p:cNvSpPr/>
+          <p:nvPr/>
+        </p:nvSpPr>
+        <p:spPr>
+          <a:xfrm>
+            <a:off x="2606040" y="5303520"/>
+            <a:ext cx="5212080" cy="749808"/>
+          </a:xfrm>
+          <a:prstGeom prst="rect">
+            <a:avLst/>
+          </a:prstGeom>
+          <a:noFill/>
+          <a:ln/>
+        </p:spPr>
+        <p:txBody>
+          <a:bodyPr wrap="square" rtlCol="0" anchor="ctr"/>
+          <a:lstStyle/>
+          <a:p>
+            <a:pPr indent="0" marL="0">
+              <a:buNone/>
+            </a:pPr>
+            <a:r>
+              <a:rPr lang="en-US" sz="1300" dirty="0">
+                <a:solidFill>
+                  <a:srgbClr val="F5F5F5"/>
+                </a:solidFill>
+                <a:latin typeface="Arial" pitchFamily="34" charset="0"/>
+                <a:ea typeface="Arial" pitchFamily="34" charset="-122"/>
+                <a:cs typeface="Arial" pitchFamily="34" charset="-120"/>
+              </a:rPr>
+              <a:t>Día de actividad sin validar</a:t>
+            </a:r>
+            <a:endParaRPr lang="en-US" sz="1300" dirty="0"/>
+          </a:p>
+        </p:txBody>
+      </p:sp>
+      <p:sp>
+        <p:nvSpPr>
+          <p:cNvPr id="25" name="Text 23"/>
+          <p:cNvSpPr/>
+          <p:nvPr/>
+        </p:nvSpPr>
+        <p:spPr>
+          <a:xfrm>
+            <a:off x="7955280" y="5303520"/>
+            <a:ext cx="3657600" cy="749808"/>
+          </a:xfrm>
+          <a:prstGeom prst="rect">
+            <a:avLst/>
+          </a:prstGeom>
+          <a:noFill/>
+          <a:ln/>
+        </p:spPr>
+        <p:txBody>
+          <a:bodyPr wrap="square" rtlCol="0" anchor="ctr"/>
+          <a:lstStyle/>
+          <a:p>
+            <a:pPr indent="0" marL="0">
+              <a:buNone/>
+            </a:pPr>
+            <a:r>
+              <a:rPr lang="en-US" sz="1300" b="1" dirty="0">
+                <a:solidFill>
+                  <a:srgbClr val="3DD68C"/>
+                </a:solidFill>
+                <a:latin typeface="Arial Black" pitchFamily="34" charset="0"/>
+                <a:ea typeface="Arial Black" pitchFamily="34" charset="-122"/>
+                <a:cs typeface="Arial Black" pitchFamily="34" charset="-120"/>
+              </a:rPr>
               <a:t>→ 400 con @Pattern</a:t>
             </a:r>
             <a:endParaRPr lang="en-US" sz="1300" dirty="0"/>
@@ -6870,7 +7177,7 @@
       </p:sp>
       <p:sp>
         <p:nvSpPr>
-          <p:cNvPr id="22" name="Text 20"/>
+          <p:cNvPr id="26" name="Text 24"/>
           <p:cNvSpPr/>
           <p:nvPr/>
         </p:nvSpPr>
@@ -6958,6 +7265,10 @@
           </a:solidFill>
           <a:ln/>
         </p:spPr>
+        <p:txBody>
+          <a:bodyPr/>
+          <a:p/>
+        </p:txBody>
       </p:sp>
       <p:sp>
         <p:nvSpPr>
@@ -7097,6 +7408,10 @@
           </a:solidFill>
           <a:ln/>
         </p:spPr>
+        <p:txBody>
+          <a:bodyPr/>
+          <a:p/>
+        </p:txBody>
       </p:sp>
       <p:sp>
         <p:nvSpPr>
@@ -7117,6 +7432,10 @@
           </a:solidFill>
           <a:ln/>
         </p:spPr>
+        <p:txBody>
+          <a:bodyPr/>
+          <a:p/>
+        </p:txBody>
       </p:sp>
       <p:sp>
         <p:nvSpPr>
@@ -7217,6 +7536,10 @@
           </a:solidFill>
           <a:ln/>
         </p:spPr>
+        <p:txBody>
+          <a:bodyPr/>
+          <a:p/>
+        </p:txBody>
       </p:sp>
       <p:sp>
         <p:nvSpPr>
@@ -7237,6 +7560,10 @@
           </a:solidFill>
           <a:ln/>
         </p:spPr>
+        <p:txBody>
+          <a:bodyPr/>
+          <a:p/>
+        </p:txBody>
       </p:sp>
       <p:sp>
         <p:nvSpPr>
@@ -7337,6 +7664,10 @@
           </a:solidFill>
           <a:ln/>
         </p:spPr>
+        <p:txBody>
+          <a:bodyPr/>
+          <a:p/>
+        </p:txBody>
       </p:sp>
       <p:sp>
         <p:nvSpPr>
@@ -7357,6 +7688,10 @@
           </a:solidFill>
           <a:ln/>
         </p:spPr>
+        <p:txBody>
+          <a:bodyPr/>
+          <a:p/>
+        </p:txBody>
       </p:sp>
       <p:sp>
         <p:nvSpPr>
@@ -7526,6 +7861,10 @@
           </a:solidFill>
           <a:ln/>
         </p:spPr>
+        <p:txBody>
+          <a:bodyPr/>
+          <a:p/>
+        </p:txBody>
       </p:sp>
       <p:sp>
         <p:nvSpPr>
@@ -7704,6 +8043,10 @@
           </a:solidFill>
           <a:ln/>
         </p:spPr>
+        <p:txBody>
+          <a:bodyPr/>
+          <a:p/>
+        </p:txBody>
       </p:sp>
       <p:sp>
         <p:nvSpPr>
@@ -7724,6 +8067,10 @@
           </a:solidFill>
           <a:ln/>
         </p:spPr>
+        <p:txBody>
+          <a:bodyPr/>
+          <a:p/>
+        </p:txBody>
       </p:sp>
       <p:sp>
         <p:nvSpPr>
@@ -7863,6 +8210,10 @@
           </a:solidFill>
           <a:ln/>
         </p:spPr>
+        <p:txBody>
+          <a:bodyPr/>
+          <a:p/>
+        </p:txBody>
       </p:sp>
       <p:sp>
         <p:nvSpPr>
@@ -7883,6 +8234,10 @@
           </a:solidFill>
           <a:ln/>
         </p:spPr>
+        <p:txBody>
+          <a:bodyPr/>
+          <a:p/>
+        </p:txBody>
       </p:sp>
       <p:sp>
         <p:nvSpPr>
@@ -8022,6 +8377,10 @@
           </a:solidFill>
           <a:ln/>
         </p:spPr>
+        <p:txBody>
+          <a:bodyPr/>
+          <a:p/>
+        </p:txBody>
       </p:sp>
       <p:sp>
         <p:nvSpPr>
@@ -8042,6 +8401,10 @@
           </a:solidFill>
           <a:ln/>
         </p:spPr>
+        <p:txBody>
+          <a:bodyPr/>
+          <a:p/>
+        </p:txBody>
       </p:sp>
       <p:sp>
         <p:nvSpPr>
@@ -8289,6 +8652,10 @@
           </a:solidFill>
           <a:ln/>
         </p:spPr>
+        <p:txBody>
+          <a:bodyPr/>
+          <a:p/>
+        </p:txBody>
       </p:sp>
       <p:sp>
         <p:nvSpPr>
@@ -8433,6 +8800,10 @@
             <a:prstDash val="solid"/>
           </a:ln>
         </p:spPr>
+        <p:txBody>
+          <a:bodyPr/>
+          <a:p/>
+        </p:txBody>
       </p:sp>
       <p:sp>
         <p:nvSpPr>
@@ -8641,6 +9012,10 @@
           </a:solidFill>
           <a:ln/>
         </p:spPr>
+        <p:txBody>
+          <a:bodyPr/>
+          <a:p/>
+        </p:txBody>
       </p:sp>
       <p:sp>
         <p:nvSpPr>
@@ -8780,6 +9155,10 @@
           </a:solidFill>
           <a:ln/>
         </p:spPr>
+        <p:txBody>
+          <a:bodyPr/>
+          <a:p/>
+        </p:txBody>
       </p:sp>
       <p:sp>
         <p:nvSpPr>
@@ -8800,6 +9179,10 @@
           </a:solidFill>
           <a:ln/>
         </p:spPr>
+        <p:txBody>
+          <a:bodyPr/>
+          <a:p/>
+        </p:txBody>
       </p:sp>
       <p:sp>
         <p:nvSpPr>
@@ -8900,6 +9283,10 @@
           </a:solidFill>
           <a:ln/>
         </p:spPr>
+        <p:txBody>
+          <a:bodyPr/>
+          <a:p/>
+        </p:txBody>
       </p:sp>
       <p:sp>
         <p:nvSpPr>
@@ -8920,6 +9307,10 @@
           </a:solidFill>
           <a:ln/>
         </p:spPr>
+        <p:txBody>
+          <a:bodyPr/>
+          <a:p/>
+        </p:txBody>
       </p:sp>
       <p:sp>
         <p:nvSpPr>
@@ -9089,6 +9480,10 @@
           </a:solidFill>
           <a:ln/>
         </p:spPr>
+        <p:txBody>
+          <a:bodyPr/>
+          <a:p/>
+        </p:txBody>
       </p:sp>
       <p:sp>
         <p:nvSpPr>
@@ -9228,6 +9623,10 @@
           </a:solidFill>
           <a:ln/>
         </p:spPr>
+        <p:txBody>
+          <a:bodyPr/>
+          <a:p/>
+        </p:txBody>
       </p:sp>
       <p:sp>
         <p:nvSpPr>
@@ -9248,6 +9647,10 @@
           </a:solidFill>
           <a:ln/>
         </p:spPr>
+        <p:txBody>
+          <a:bodyPr/>
+          <a:p/>
+        </p:txBody>
       </p:sp>
       <p:sp>
         <p:nvSpPr>
@@ -9348,6 +9751,10 @@
           </a:solidFill>
           <a:ln/>
         </p:spPr>
+        <p:txBody>
+          <a:bodyPr/>
+          <a:p/>
+        </p:txBody>
       </p:sp>
       <p:sp>
         <p:nvSpPr>
@@ -9368,6 +9775,10 @@
           </a:solidFill>
           <a:ln/>
         </p:spPr>
+        <p:txBody>
+          <a:bodyPr/>
+          <a:p/>
+        </p:txBody>
       </p:sp>
       <p:sp>
         <p:nvSpPr>
@@ -9468,6 +9879,10 @@
           </a:solidFill>
           <a:ln/>
         </p:spPr>
+        <p:txBody>
+          <a:bodyPr/>
+          <a:p/>
+        </p:txBody>
       </p:sp>
       <p:sp>
         <p:nvSpPr>
@@ -9488,6 +9903,10 @@
           </a:solidFill>
           <a:ln/>
         </p:spPr>
+        <p:txBody>
+          <a:bodyPr/>
+          <a:p/>
+        </p:txBody>
       </p:sp>
       <p:sp>
         <p:nvSpPr>
@@ -9588,6 +10007,10 @@
           </a:solidFill>
           <a:ln/>
         </p:spPr>
+        <p:txBody>
+          <a:bodyPr/>
+          <a:p/>
+        </p:txBody>
       </p:sp>
       <p:sp>
         <p:nvSpPr>
@@ -9608,6 +10031,10 @@
           </a:solidFill>
           <a:ln/>
         </p:spPr>
+        <p:txBody>
+          <a:bodyPr/>
+          <a:p/>
+        </p:txBody>
       </p:sp>
       <p:sp>
         <p:nvSpPr>
@@ -9777,6 +10204,10 @@
           </a:solidFill>
           <a:ln/>
         </p:spPr>
+        <p:txBody>
+          <a:bodyPr/>
+          <a:p/>
+        </p:txBody>
       </p:sp>
       <p:sp>
         <p:nvSpPr>
@@ -9797,6 +10228,10 @@
           </a:solidFill>
           <a:ln/>
         </p:spPr>
+        <p:txBody>
+          <a:bodyPr/>
+          <a:p/>
+        </p:txBody>
       </p:sp>
       <p:sp>
         <p:nvSpPr>
@@ -9926,7 +10361,7 @@
                 <a:ea typeface="Arial" pitchFamily="34" charset="-122"/>
                 <a:cs typeface="Arial" pitchFamily="34" charset="-120"/>
               </a:rPr>
-              <a:t>77 tests verdes  ·  100% en módulos principales  ·  CI activo  ·  trazabilidad completa  ·  defecto crítico cerrado</a:t>
+              <a:t>78 tests verdes  ·  100% en módulos principales  ·  CI activo  ·  trazabilidad completa  ·  defecto crítico cerrado</a:t>
             </a:r>
             <a:endParaRPr lang="en-US" sz="1600" dirty="0"/>
           </a:p>
@@ -10022,6 +10457,10 @@
           </a:solidFill>
           <a:ln/>
         </p:spPr>
+        <p:txBody>
+          <a:bodyPr/>
+          <a:p/>
+        </p:txBody>
       </p:sp>
       <p:sp>
         <p:nvSpPr>
@@ -10200,6 +10639,10 @@
           </a:solidFill>
           <a:ln/>
         </p:spPr>
+        <p:txBody>
+          <a:bodyPr/>
+          <a:p/>
+        </p:txBody>
       </p:sp>
       <p:sp>
         <p:nvSpPr>
@@ -10220,6 +10663,10 @@
           </a:solidFill>
           <a:ln/>
         </p:spPr>
+        <p:txBody>
+          <a:bodyPr/>
+          <a:p/>
+        </p:txBody>
       </p:sp>
       <p:sp>
         <p:nvSpPr>
@@ -10320,6 +10767,10 @@
           </a:solidFill>
           <a:ln/>
         </p:spPr>
+        <p:txBody>
+          <a:bodyPr/>
+          <a:p/>
+        </p:txBody>
       </p:sp>
       <p:sp>
         <p:nvSpPr>
@@ -10340,6 +10791,10 @@
           </a:solidFill>
           <a:ln/>
         </p:spPr>
+        <p:txBody>
+          <a:bodyPr/>
+          <a:p/>
+        </p:txBody>
       </p:sp>
       <p:sp>
         <p:nvSpPr>
@@ -10440,6 +10895,10 @@
           </a:solidFill>
           <a:ln/>
         </p:spPr>
+        <p:txBody>
+          <a:bodyPr/>
+          <a:p/>
+        </p:txBody>
       </p:sp>
       <p:sp>
         <p:nvSpPr>
@@ -10460,6 +10919,10 @@
           </a:solidFill>
           <a:ln/>
         </p:spPr>
+        <p:txBody>
+          <a:bodyPr/>
+          <a:p/>
+        </p:txBody>
       </p:sp>
       <p:sp>
         <p:nvSpPr>
@@ -10560,6 +11023,10 @@
           </a:solidFill>
           <a:ln/>
         </p:spPr>
+        <p:txBody>
+          <a:bodyPr/>
+          <a:p/>
+        </p:txBody>
       </p:sp>
       <p:sp>
         <p:nvSpPr>
@@ -10580,6 +11047,10 @@
           </a:solidFill>
           <a:ln/>
         </p:spPr>
+        <p:txBody>
+          <a:bodyPr/>
+          <a:p/>
+        </p:txBody>
       </p:sp>
       <p:sp>
         <p:nvSpPr>
@@ -10749,6 +11220,10 @@
           </a:solidFill>
           <a:ln/>
         </p:spPr>
+        <p:txBody>
+          <a:bodyPr/>
+          <a:p/>
+        </p:txBody>
       </p:sp>
       <p:sp>
         <p:nvSpPr>
@@ -10888,6 +11363,10 @@
           </a:solidFill>
           <a:ln/>
         </p:spPr>
+        <p:txBody>
+          <a:bodyPr/>
+          <a:p/>
+        </p:txBody>
       </p:sp>
       <p:sp>
         <p:nvSpPr>
@@ -10908,6 +11387,10 @@
           </a:solidFill>
           <a:ln/>
         </p:spPr>
+        <p:txBody>
+          <a:bodyPr/>
+          <a:p/>
+        </p:txBody>
       </p:sp>
       <p:sp>
         <p:nvSpPr>
@@ -11047,6 +11530,10 @@
           </a:solidFill>
           <a:ln/>
         </p:spPr>
+        <p:txBody>
+          <a:bodyPr/>
+          <a:p/>
+        </p:txBody>
       </p:sp>
       <p:sp>
         <p:nvSpPr>
@@ -11067,6 +11554,10 @@
           </a:solidFill>
           <a:ln/>
         </p:spPr>
+        <p:txBody>
+          <a:bodyPr/>
+          <a:p/>
+        </p:txBody>
       </p:sp>
       <p:sp>
         <p:nvSpPr>
@@ -11206,6 +11697,10 @@
           </a:solidFill>
           <a:ln/>
         </p:spPr>
+        <p:txBody>
+          <a:bodyPr/>
+          <a:p/>
+        </p:txBody>
       </p:sp>
       <p:sp>
         <p:nvSpPr>
@@ -11226,6 +11721,10 @@
           </a:solidFill>
           <a:ln/>
         </p:spPr>
+        <p:txBody>
+          <a:bodyPr/>
+          <a:p/>
+        </p:txBody>
       </p:sp>
       <p:sp>
         <p:nvSpPr>
@@ -11365,6 +11864,10 @@
           </a:solidFill>
           <a:ln/>
         </p:spPr>
+        <p:txBody>
+          <a:bodyPr/>
+          <a:p/>
+        </p:txBody>
       </p:sp>
       <p:sp>
         <p:nvSpPr>
@@ -11385,6 +11888,10 @@
           </a:solidFill>
           <a:ln/>
         </p:spPr>
+        <p:txBody>
+          <a:bodyPr/>
+          <a:p/>
+        </p:txBody>
       </p:sp>
       <p:sp>
         <p:nvSpPr>
@@ -11593,6 +12100,10 @@
           </a:solidFill>
           <a:ln/>
         </p:spPr>
+        <p:txBody>
+          <a:bodyPr/>
+          <a:p/>
+        </p:txBody>
       </p:sp>
       <p:sp>
         <p:nvSpPr>
@@ -11732,6 +12243,10 @@
           </a:solidFill>
           <a:ln/>
         </p:spPr>
+        <p:txBody>
+          <a:bodyPr/>
+          <a:p/>
+        </p:txBody>
       </p:sp>
       <p:sp>
         <p:nvSpPr>
@@ -11752,6 +12267,10 @@
           </a:solidFill>
           <a:ln/>
         </p:spPr>
+        <p:txBody>
+          <a:bodyPr/>
+          <a:p/>
+        </p:txBody>
       </p:sp>
       <p:sp>
         <p:nvSpPr>
@@ -11852,6 +12371,10 @@
           </a:solidFill>
           <a:ln/>
         </p:spPr>
+        <p:txBody>
+          <a:bodyPr/>
+          <a:p/>
+        </p:txBody>
       </p:sp>
       <p:sp>
         <p:nvSpPr>
@@ -11872,6 +12395,10 @@
           </a:solidFill>
           <a:ln/>
         </p:spPr>
+        <p:txBody>
+          <a:bodyPr/>
+          <a:p/>
+        </p:txBody>
       </p:sp>
       <p:sp>
         <p:nvSpPr>
@@ -11972,6 +12499,10 @@
           </a:solidFill>
           <a:ln/>
         </p:spPr>
+        <p:txBody>
+          <a:bodyPr/>
+          <a:p/>
+        </p:txBody>
       </p:sp>
       <p:sp>
         <p:nvSpPr>
@@ -11992,6 +12523,10 @@
           </a:solidFill>
           <a:ln/>
         </p:spPr>
+        <p:txBody>
+          <a:bodyPr/>
+          <a:p/>
+        </p:txBody>
       </p:sp>
       <p:sp>
         <p:nvSpPr>
@@ -12161,6 +12696,10 @@
           </a:solidFill>
           <a:ln/>
         </p:spPr>
+        <p:txBody>
+          <a:bodyPr/>
+          <a:p/>
+        </p:txBody>
       </p:sp>
       <p:sp>
         <p:nvSpPr>
@@ -12300,6 +12839,10 @@
           </a:solidFill>
           <a:ln/>
         </p:spPr>
+        <p:txBody>
+          <a:bodyPr/>
+          <a:p/>
+        </p:txBody>
       </p:sp>
       <p:sp>
         <p:nvSpPr>
@@ -12478,6 +13021,10 @@
           </a:solidFill>
           <a:ln/>
         </p:spPr>
+        <p:txBody>
+          <a:bodyPr/>
+          <a:p/>
+        </p:txBody>
       </p:sp>
       <p:sp>
         <p:nvSpPr>
@@ -12656,6 +13203,10 @@
           </a:solidFill>
           <a:ln/>
         </p:spPr>
+        <p:txBody>
+          <a:bodyPr/>
+          <a:p/>
+        </p:txBody>
       </p:sp>
       <p:sp>
         <p:nvSpPr>
@@ -12834,6 +13385,10 @@
           </a:solidFill>
           <a:ln/>
         </p:spPr>
+        <p:txBody>
+          <a:bodyPr/>
+          <a:p/>
+        </p:txBody>
       </p:sp>
       <p:sp>
         <p:nvSpPr>
@@ -13012,6 +13567,10 @@
           </a:solidFill>
           <a:ln/>
         </p:spPr>
+        <p:txBody>
+          <a:bodyPr/>
+          <a:p/>
+        </p:txBody>
       </p:sp>
       <p:sp>
         <p:nvSpPr>
@@ -13259,6 +13818,10 @@
           </a:solidFill>
           <a:ln/>
         </p:spPr>
+        <p:txBody>
+          <a:bodyPr/>
+          <a:p/>
+        </p:txBody>
       </p:sp>
       <p:sp>
         <p:nvSpPr>
@@ -13398,6 +13961,10 @@
           </a:solidFill>
           <a:ln/>
         </p:spPr>
+        <p:txBody>
+          <a:bodyPr/>
+          <a:p/>
+        </p:txBody>
       </p:sp>
       <p:sp>
         <p:nvSpPr>
@@ -13418,6 +13985,10 @@
           </a:solidFill>
           <a:ln/>
         </p:spPr>
+        <p:txBody>
+          <a:bodyPr/>
+          <a:p/>
+        </p:txBody>
       </p:sp>
       <p:sp>
         <p:nvSpPr>
@@ -13518,6 +14089,10 @@
           </a:solidFill>
           <a:ln/>
         </p:spPr>
+        <p:txBody>
+          <a:bodyPr/>
+          <a:p/>
+        </p:txBody>
       </p:sp>
       <p:sp>
         <p:nvSpPr>
@@ -13538,6 +14113,10 @@
           </a:solidFill>
           <a:ln/>
         </p:spPr>
+        <p:txBody>
+          <a:bodyPr/>
+          <a:p/>
+        </p:txBody>
       </p:sp>
       <p:sp>
         <p:nvSpPr>
@@ -13638,6 +14217,10 @@
           </a:solidFill>
           <a:ln/>
         </p:spPr>
+        <p:txBody>
+          <a:bodyPr/>
+          <a:p/>
+        </p:txBody>
       </p:sp>
       <p:sp>
         <p:nvSpPr>
@@ -13658,6 +14241,10 @@
           </a:solidFill>
           <a:ln/>
         </p:spPr>
+        <p:txBody>
+          <a:bodyPr/>
+          <a:p/>
+        </p:txBody>
       </p:sp>
       <p:sp>
         <p:nvSpPr>
@@ -13866,6 +14453,10 @@
           </a:solidFill>
           <a:ln/>
         </p:spPr>
+        <p:txBody>
+          <a:bodyPr/>
+          <a:p/>
+        </p:txBody>
       </p:sp>
       <p:sp>
         <p:nvSpPr>
@@ -14005,6 +14596,10 @@
           </a:solidFill>
           <a:ln/>
         </p:spPr>
+        <p:txBody>
+          <a:bodyPr/>
+          <a:p/>
+        </p:txBody>
       </p:sp>
       <p:sp>
         <p:nvSpPr>
@@ -14025,6 +14620,10 @@
           </a:solidFill>
           <a:ln/>
         </p:spPr>
+        <p:txBody>
+          <a:bodyPr/>
+          <a:p/>
+        </p:txBody>
       </p:sp>
       <p:sp>
         <p:nvSpPr>
@@ -14059,7 +14658,7 @@
                 <a:ea typeface="Arial Black" pitchFamily="34" charset="-122"/>
                 <a:cs typeface="Arial Black" pitchFamily="34" charset="-120"/>
               </a:rPr>
-              <a:t>55 · caja negra</a:t>
+              <a:t>56 · caja negra</a:t>
             </a:r>
             <a:endParaRPr lang="en-US" sz="3000" dirty="0"/>
           </a:p>
@@ -14164,6 +14763,10 @@
           </a:solidFill>
           <a:ln/>
         </p:spPr>
+        <p:txBody>
+          <a:bodyPr/>
+          <a:p/>
+        </p:txBody>
       </p:sp>
       <p:sp>
         <p:nvSpPr>
@@ -14184,6 +14787,10 @@
           </a:solidFill>
           <a:ln/>
         </p:spPr>
+        <p:txBody>
+          <a:bodyPr/>
+          <a:p/>
+        </p:txBody>
       </p:sp>
       <p:sp>
         <p:nvSpPr>
@@ -14431,6 +15038,10 @@
           </a:solidFill>
           <a:ln/>
         </p:spPr>
+        <p:txBody>
+          <a:bodyPr/>
+          <a:p/>
+        </p:txBody>
       </p:sp>
       <p:sp>
         <p:nvSpPr>
@@ -14570,6 +15181,10 @@
           </a:solidFill>
           <a:ln/>
         </p:spPr>
+        <p:txBody>
+          <a:bodyPr/>
+          <a:p/>
+        </p:txBody>
       </p:sp>
       <p:sp>
         <p:nvSpPr>
@@ -14590,6 +15205,10 @@
           </a:solidFill>
           <a:ln/>
         </p:spPr>
+        <p:txBody>
+          <a:bodyPr/>
+          <a:p/>
+        </p:txBody>
       </p:sp>
       <p:sp>
         <p:nvSpPr>
@@ -14690,6 +15309,10 @@
           </a:solidFill>
           <a:ln/>
         </p:spPr>
+        <p:txBody>
+          <a:bodyPr/>
+          <a:p/>
+        </p:txBody>
       </p:sp>
       <p:sp>
         <p:nvSpPr>
@@ -14710,6 +15333,10 @@
           </a:solidFill>
           <a:ln/>
         </p:spPr>
+        <p:txBody>
+          <a:bodyPr/>
+          <a:p/>
+        </p:txBody>
       </p:sp>
       <p:sp>
         <p:nvSpPr>
@@ -14810,6 +15437,10 @@
           </a:solidFill>
           <a:ln/>
         </p:spPr>
+        <p:txBody>
+          <a:bodyPr/>
+          <a:p/>
+        </p:txBody>
       </p:sp>
       <p:sp>
         <p:nvSpPr>
@@ -14830,6 +15461,10 @@
           </a:solidFill>
           <a:ln/>
         </p:spPr>
+        <p:txBody>
+          <a:bodyPr/>
+          <a:p/>
+        </p:txBody>
       </p:sp>
       <p:sp>
         <p:nvSpPr>

</xml_diff>